<commit_message>
Session data and output updates 2026-04-13
- Update 4月着地見込サマリー.pptx
- Update session files

Co-Authored-By: Claude Sonnet 4.6 <noreply@anthropic.com>
</commit_message>
<xml_diff>
--- a/output/SHUWAN_4月着地見込サマリー.pptx
+++ b/output/SHUWAN_4月着地見込サマリー.pptx
@@ -5,12 +5,13 @@
     <p:sldMasterId id="2147483648" r:id="rId1"/>
   </p:sldMasterIdLst>
   <p:notesMasterIdLst>
-    <p:notesMasterId r:id="rId5"/>
+    <p:notesMasterId r:id="rId6"/>
   </p:notesMasterIdLst>
   <p:sldIdLst>
     <p:sldId id="256" r:id="rId2"/>
     <p:sldId id="257" r:id="rId3"/>
     <p:sldId id="258" r:id="rId4"/>
+    <p:sldId id="259" r:id="rId5"/>
   </p:sldIdLst>
   <p:sldSz cx="12192000" cy="6858000"/>
   <p:notesSz cx="6858000" cy="12192000"/>
@@ -10632,6 +10633,176 @@
 </p:sld>
 </file>
 
+<file path=ppt/slides/slide4.xml><?xml version="1.0" encoding="utf-8"?>
+<p:sld xmlns:a="http://schemas.openxmlformats.org/drawingml/2006/main" xmlns:r="http://schemas.openxmlformats.org/officeDocument/2006/relationships" xmlns:p="http://schemas.openxmlformats.org/presentationml/2006/main">
+  <p:cSld>
+    <p:spTree>
+      <p:nvGrpSpPr>
+        <p:cNvPr id="1" name=""/>
+        <p:cNvGrpSpPr/>
+        <p:nvPr/>
+      </p:nvGrpSpPr>
+      <p:grpSpPr>
+        <a:xfrm>
+          <a:off x="0" y="0"/>
+          <a:ext cx="0" cy="0"/>
+          <a:chOff x="0" y="0"/>
+          <a:chExt cx="0" cy="0"/>
+        </a:xfrm>
+      </p:grpSpPr>
+      <p:sp>
+        <p:nvSpPr>
+          <p:cNvPr id="2" name="Text 12">
+            <a:extLst>
+              <a:ext uri="{FF2B5EF4-FFF2-40B4-BE49-F238E27FC236}">
+                <a16:creationId xmlns:a16="http://schemas.microsoft.com/office/drawing/2014/main" id="{4FBB6344-D6A9-1C4E-FD47-882B293CC316}"/>
+              </a:ext>
+            </a:extLst>
+          </p:cNvPr>
+          <p:cNvSpPr/>
+          <p:nvPr/>
+        </p:nvSpPr>
+        <p:spPr>
+          <a:xfrm>
+            <a:off x="796413" y="1479755"/>
+            <a:ext cx="10058400" cy="1288026"/>
+          </a:xfrm>
+          <a:prstGeom prst="rect">
+            <a:avLst/>
+          </a:prstGeom>
+          <a:noFill/>
+          <a:ln/>
+        </p:spPr>
+        <p:txBody>
+          <a:bodyPr wrap="square" lIns="0" tIns="0" rIns="0" bIns="0" rtlCol="0" anchor="ctr"/>
+          <a:lstStyle/>
+          <a:p>
+            <a:pPr marL="0" indent="0">
+              <a:buNone/>
+            </a:pPr>
+            <a:r>
+              <a:rPr lang="ja-JP" altLang="en-US" sz="2600" b="1" dirty="0">
+                <a:solidFill>
+                  <a:srgbClr val="222222"/>
+                </a:solidFill>
+                <a:latin typeface="Calibri" pitchFamily="34" charset="0"/>
+                <a:ea typeface="Calibri" pitchFamily="34" charset="-122"/>
+                <a:cs typeface="Calibri" pitchFamily="34" charset="-120"/>
+              </a:rPr>
+              <a:t>・</a:t>
+            </a:r>
+            <a:r>
+              <a:rPr lang="en-US" altLang="ja-JP" sz="2600" b="1" dirty="0">
+                <a:solidFill>
+                  <a:srgbClr val="222222"/>
+                </a:solidFill>
+                <a:latin typeface="Calibri" pitchFamily="34" charset="0"/>
+                <a:ea typeface="Calibri" pitchFamily="34" charset="-122"/>
+                <a:cs typeface="Calibri" pitchFamily="34" charset="-120"/>
+              </a:rPr>
+              <a:t>Meta</a:t>
+            </a:r>
+            <a:r>
+              <a:rPr lang="ja-JP" altLang="en-US" sz="2600" b="1" dirty="0">
+                <a:solidFill>
+                  <a:srgbClr val="222222"/>
+                </a:solidFill>
+                <a:latin typeface="Calibri" pitchFamily="34" charset="0"/>
+                <a:ea typeface="Calibri" pitchFamily="34" charset="-122"/>
+                <a:cs typeface="Calibri" pitchFamily="34" charset="-120"/>
+              </a:rPr>
+              <a:t>の広告開始で、土日で</a:t>
+            </a:r>
+            <a:r>
+              <a:rPr lang="en-US" altLang="ja-JP" sz="2600" b="1" dirty="0">
+                <a:solidFill>
+                  <a:srgbClr val="222222"/>
+                </a:solidFill>
+                <a:latin typeface="Calibri" pitchFamily="34" charset="0"/>
+                <a:ea typeface="Calibri" pitchFamily="34" charset="-122"/>
+                <a:cs typeface="Calibri" pitchFamily="34" charset="-120"/>
+              </a:rPr>
+              <a:t>20</a:t>
+            </a:r>
+            <a:r>
+              <a:rPr lang="ja-JP" altLang="en-US" sz="2600" b="1" dirty="0">
+                <a:solidFill>
+                  <a:srgbClr val="222222"/>
+                </a:solidFill>
+                <a:latin typeface="Calibri" pitchFamily="34" charset="0"/>
+                <a:ea typeface="Calibri" pitchFamily="34" charset="-122"/>
+                <a:cs typeface="Calibri" pitchFamily="34" charset="-120"/>
+              </a:rPr>
+              <a:t>件注文あり。（通常比）</a:t>
+            </a:r>
+            <a:endParaRPr lang="en-US" altLang="ja-JP" sz="2600" b="1" dirty="0">
+              <a:solidFill>
+                <a:srgbClr val="222222"/>
+              </a:solidFill>
+              <a:latin typeface="Calibri" pitchFamily="34" charset="0"/>
+              <a:ea typeface="Calibri" pitchFamily="34" charset="-122"/>
+              <a:cs typeface="Calibri" pitchFamily="34" charset="-120"/>
+            </a:endParaRPr>
+          </a:p>
+          <a:p>
+            <a:pPr marL="0" indent="0">
+              <a:buNone/>
+            </a:pPr>
+            <a:r>
+              <a:rPr lang="ja-JP" altLang="en-US" sz="2600" dirty="0"/>
+              <a:t>・問い合わせ</a:t>
+            </a:r>
+            <a:r>
+              <a:rPr lang="en-US" altLang="ja-JP" sz="2600" dirty="0"/>
+              <a:t>1</a:t>
+            </a:r>
+            <a:r>
+              <a:rPr lang="ja-JP" altLang="en-US" sz="2600" dirty="0"/>
+              <a:t>件（経由をヒアリング）　</a:t>
+            </a:r>
+            <a:endParaRPr lang="en-US" altLang="ja-JP" sz="2600" dirty="0"/>
+          </a:p>
+          <a:p>
+            <a:pPr marL="0" indent="0">
+              <a:buNone/>
+            </a:pPr>
+            <a:r>
+              <a:rPr lang="ja-JP" altLang="en-US" sz="2600" dirty="0"/>
+              <a:t>・</a:t>
+            </a:r>
+            <a:r>
+              <a:rPr lang="en-US" altLang="ja-JP" sz="2600" dirty="0"/>
+              <a:t>Amazon</a:t>
+            </a:r>
+            <a:r>
+              <a:rPr lang="ja-JP" altLang="en-US" sz="2600" dirty="0"/>
+              <a:t>で大口注文　</a:t>
+            </a:r>
+            <a:r>
+              <a:rPr lang="en-US" altLang="ja-JP" sz="2600" dirty="0"/>
+              <a:t>13</a:t>
+            </a:r>
+            <a:r>
+              <a:rPr lang="ja-JP" altLang="en-US" sz="2600" dirty="0"/>
+              <a:t>件（経由をヒアリング）</a:t>
+            </a:r>
+            <a:endParaRPr lang="en-US" altLang="ja-JP" sz="2600" dirty="0"/>
+          </a:p>
+        </p:txBody>
+      </p:sp>
+    </p:spTree>
+    <p:extLst>
+      <p:ext uri="{BB962C8B-B14F-4D97-AF65-F5344CB8AC3E}">
+        <p14:creationId xmlns:p14="http://schemas.microsoft.com/office/powerpoint/2010/main" val="2507079482"/>
+      </p:ext>
+    </p:extLst>
+  </p:cSld>
+  <p:clrMapOvr>
+    <a:masterClrMapping/>
+  </p:clrMapOvr>
+</p:sld>
+</file>
+
 <file path=ppt/theme/theme1.xml><?xml version="1.0" encoding="utf-8"?>
 <a:theme xmlns:a="http://schemas.openxmlformats.org/drawingml/2006/main" name="Office Theme">
   <a:themeElements>

</xml_diff>

<commit_message>
Update session data and outputs 2026-04-13
Co-Authored-By: Claude Sonnet 4.6 <noreply@anthropic.com>
</commit_message>
<xml_diff>
--- a/output/SHUWAN_4月着地見込サマリー.pptx
+++ b/output/SHUWAN_4月着地見込サマリー.pptx
@@ -10664,8 +10664,8 @@
         </p:nvSpPr>
         <p:spPr>
           <a:xfrm>
-            <a:off x="796413" y="1479755"/>
-            <a:ext cx="10058400" cy="1288026"/>
+            <a:off x="796413" y="722672"/>
+            <a:ext cx="10058400" cy="2954592"/>
           </a:xfrm>
           <a:prstGeom prst="rect">
             <a:avLst/>
@@ -10676,6 +10676,197 @@
         <p:txBody>
           <a:bodyPr wrap="square" lIns="0" tIns="0" rIns="0" bIns="0" rtlCol="0" anchor="ctr"/>
           <a:lstStyle/>
+          <a:p>
+            <a:pPr marL="0" indent="0">
+              <a:buNone/>
+            </a:pPr>
+            <a:r>
+              <a:rPr lang="ja-JP" altLang="en-US" sz="2600" b="1" dirty="0">
+                <a:solidFill>
+                  <a:srgbClr val="222222"/>
+                </a:solidFill>
+                <a:latin typeface="Calibri" pitchFamily="34" charset="0"/>
+                <a:ea typeface="Calibri" pitchFamily="34" charset="-122"/>
+                <a:cs typeface="Calibri" pitchFamily="34" charset="-120"/>
+              </a:rPr>
+              <a:t>・</a:t>
+            </a:r>
+            <a:r>
+              <a:rPr lang="en-US" altLang="ja-JP" sz="2600" b="1" dirty="0">
+                <a:solidFill>
+                  <a:srgbClr val="222222"/>
+                </a:solidFill>
+                <a:latin typeface="Calibri" pitchFamily="34" charset="0"/>
+                <a:ea typeface="Calibri" pitchFamily="34" charset="-122"/>
+                <a:cs typeface="Calibri" pitchFamily="34" charset="-120"/>
+              </a:rPr>
+              <a:t>11</a:t>
+            </a:r>
+            <a:r>
+              <a:rPr lang="ja-JP" altLang="en-US" sz="2600" b="1" dirty="0">
+                <a:solidFill>
+                  <a:srgbClr val="222222"/>
+                </a:solidFill>
+                <a:latin typeface="Calibri" pitchFamily="34" charset="0"/>
+                <a:ea typeface="Calibri" pitchFamily="34" charset="-122"/>
+                <a:cs typeface="Calibri" pitchFamily="34" charset="-120"/>
+              </a:rPr>
+              <a:t>日</a:t>
+            </a:r>
+            <a:r>
+              <a:rPr lang="en-US" altLang="ja-JP" sz="2600" b="1" dirty="0">
+                <a:solidFill>
+                  <a:srgbClr val="222222"/>
+                </a:solidFill>
+                <a:latin typeface="Calibri" pitchFamily="34" charset="0"/>
+                <a:ea typeface="Calibri" pitchFamily="34" charset="-122"/>
+                <a:cs typeface="Calibri" pitchFamily="34" charset="-120"/>
+              </a:rPr>
+              <a:t>1389</a:t>
+            </a:r>
+            <a:r>
+              <a:rPr lang="ja-JP" altLang="en-US" sz="2600" b="1" dirty="0">
+                <a:solidFill>
+                  <a:srgbClr val="222222"/>
+                </a:solidFill>
+                <a:latin typeface="Calibri" pitchFamily="34" charset="0"/>
+                <a:ea typeface="Calibri" pitchFamily="34" charset="-122"/>
+                <a:cs typeface="Calibri" pitchFamily="34" charset="-120"/>
+              </a:rPr>
+              <a:t>円　</a:t>
+            </a:r>
+            <a:r>
+              <a:rPr lang="en-US" altLang="ja-JP" sz="2600" b="1" dirty="0">
+                <a:solidFill>
+                  <a:srgbClr val="222222"/>
+                </a:solidFill>
+                <a:latin typeface="Calibri" pitchFamily="34" charset="0"/>
+                <a:ea typeface="Calibri" pitchFamily="34" charset="-122"/>
+                <a:cs typeface="Calibri" pitchFamily="34" charset="-120"/>
+              </a:rPr>
+              <a:t>12</a:t>
+            </a:r>
+            <a:r>
+              <a:rPr lang="ja-JP" altLang="en-US" sz="2600" b="1" dirty="0">
+                <a:solidFill>
+                  <a:srgbClr val="222222"/>
+                </a:solidFill>
+                <a:latin typeface="Calibri" pitchFamily="34" charset="0"/>
+                <a:ea typeface="Calibri" pitchFamily="34" charset="-122"/>
+                <a:cs typeface="Calibri" pitchFamily="34" charset="-120"/>
+              </a:rPr>
+              <a:t>日</a:t>
+            </a:r>
+            <a:r>
+              <a:rPr lang="en-US" altLang="ja-JP" sz="2600" b="1" dirty="0">
+                <a:solidFill>
+                  <a:srgbClr val="222222"/>
+                </a:solidFill>
+                <a:latin typeface="Calibri" pitchFamily="34" charset="0"/>
+                <a:ea typeface="Calibri" pitchFamily="34" charset="-122"/>
+                <a:cs typeface="Calibri" pitchFamily="34" charset="-120"/>
+              </a:rPr>
+              <a:t>3499</a:t>
+            </a:r>
+            <a:r>
+              <a:rPr lang="ja-JP" altLang="en-US" sz="2600" b="1" dirty="0">
+                <a:solidFill>
+                  <a:srgbClr val="222222"/>
+                </a:solidFill>
+                <a:latin typeface="Calibri" pitchFamily="34" charset="0"/>
+                <a:ea typeface="Calibri" pitchFamily="34" charset="-122"/>
+                <a:cs typeface="Calibri" pitchFamily="34" charset="-120"/>
+              </a:rPr>
+              <a:t>円　</a:t>
+            </a:r>
+            <a:r>
+              <a:rPr lang="en-US" altLang="ja-JP" sz="2600" b="1" dirty="0">
+                <a:solidFill>
+                  <a:srgbClr val="222222"/>
+                </a:solidFill>
+                <a:latin typeface="Calibri" pitchFamily="34" charset="0"/>
+                <a:ea typeface="Calibri" pitchFamily="34" charset="-122"/>
+                <a:cs typeface="Calibri" pitchFamily="34" charset="-120"/>
+              </a:rPr>
+              <a:t>13</a:t>
+            </a:r>
+            <a:r>
+              <a:rPr lang="ja-JP" altLang="en-US" sz="2600" b="1" dirty="0">
+                <a:solidFill>
+                  <a:srgbClr val="222222"/>
+                </a:solidFill>
+                <a:latin typeface="Calibri" pitchFamily="34" charset="0"/>
+                <a:ea typeface="Calibri" pitchFamily="34" charset="-122"/>
+                <a:cs typeface="Calibri" pitchFamily="34" charset="-120"/>
+              </a:rPr>
+              <a:t>日</a:t>
+            </a:r>
+            <a:r>
+              <a:rPr lang="en-US" altLang="ja-JP" sz="2600" b="1" dirty="0">
+                <a:solidFill>
+                  <a:srgbClr val="222222"/>
+                </a:solidFill>
+                <a:latin typeface="Calibri" pitchFamily="34" charset="0"/>
+                <a:ea typeface="Calibri" pitchFamily="34" charset="-122"/>
+                <a:cs typeface="Calibri" pitchFamily="34" charset="-120"/>
+              </a:rPr>
+              <a:t>1295</a:t>
+            </a:r>
+            <a:r>
+              <a:rPr lang="ja-JP" altLang="en-US" sz="2600" b="1" dirty="0">
+                <a:solidFill>
+                  <a:srgbClr val="222222"/>
+                </a:solidFill>
+                <a:latin typeface="Calibri" pitchFamily="34" charset="0"/>
+                <a:ea typeface="Calibri" pitchFamily="34" charset="-122"/>
+                <a:cs typeface="Calibri" pitchFamily="34" charset="-120"/>
+              </a:rPr>
+              <a:t>円（日予算</a:t>
+            </a:r>
+            <a:r>
+              <a:rPr lang="en-US" altLang="ja-JP" sz="2600" b="1" dirty="0">
+                <a:solidFill>
+                  <a:srgbClr val="222222"/>
+                </a:solidFill>
+                <a:latin typeface="Calibri" pitchFamily="34" charset="0"/>
+                <a:ea typeface="Calibri" pitchFamily="34" charset="-122"/>
+                <a:cs typeface="Calibri" pitchFamily="34" charset="-120"/>
+              </a:rPr>
+              <a:t>2500</a:t>
+            </a:r>
+            <a:r>
+              <a:rPr lang="ja-JP" altLang="en-US" sz="2600" b="1" dirty="0">
+                <a:solidFill>
+                  <a:srgbClr val="222222"/>
+                </a:solidFill>
+                <a:latin typeface="Calibri" pitchFamily="34" charset="0"/>
+                <a:ea typeface="Calibri" pitchFamily="34" charset="-122"/>
+                <a:cs typeface="Calibri" pitchFamily="34" charset="-120"/>
+              </a:rPr>
+              <a:t>円）</a:t>
+            </a:r>
+            <a:endParaRPr lang="en-US" altLang="ja-JP" sz="2600" b="1" dirty="0">
+              <a:solidFill>
+                <a:srgbClr val="222222"/>
+              </a:solidFill>
+              <a:latin typeface="Calibri" pitchFamily="34" charset="0"/>
+              <a:ea typeface="Calibri" pitchFamily="34" charset="-122"/>
+              <a:cs typeface="Calibri" pitchFamily="34" charset="-120"/>
+            </a:endParaRPr>
+          </a:p>
+          <a:p>
+            <a:pPr marL="0" indent="0">
+              <a:buNone/>
+            </a:pPr>
+            <a:endParaRPr lang="en-US" altLang="ja-JP" sz="2600" b="1" dirty="0">
+              <a:solidFill>
+                <a:srgbClr val="222222"/>
+              </a:solidFill>
+              <a:latin typeface="Calibri" pitchFamily="34" charset="0"/>
+              <a:ea typeface="Calibri" pitchFamily="34" charset="-122"/>
+              <a:cs typeface="Calibri" pitchFamily="34" charset="-120"/>
+            </a:endParaRPr>
+          </a:p>
           <a:p>
             <a:pPr marL="0" indent="0">
               <a:buNone/>
@@ -10748,6 +10939,19 @@
             <a:pPr marL="0" indent="0">
               <a:buNone/>
             </a:pPr>
+            <a:endParaRPr lang="en-US" altLang="ja-JP" sz="2600" b="1" dirty="0">
+              <a:solidFill>
+                <a:srgbClr val="222222"/>
+              </a:solidFill>
+              <a:latin typeface="Calibri" pitchFamily="34" charset="0"/>
+              <a:ea typeface="Calibri" pitchFamily="34" charset="-122"/>
+              <a:cs typeface="Calibri" pitchFamily="34" charset="-120"/>
+            </a:endParaRPr>
+          </a:p>
+          <a:p>
+            <a:pPr marL="0" indent="0">
+              <a:buNone/>
+            </a:pPr>
             <a:r>
               <a:rPr lang="ja-JP" altLang="en-US" sz="2600" dirty="0"/>
               <a:t>・問い合わせ</a:t>
@@ -10785,6 +10989,46 @@
             <a:r>
               <a:rPr lang="ja-JP" altLang="en-US" sz="2600" dirty="0"/>
               <a:t>件（経由をヒアリング）</a:t>
+            </a:r>
+            <a:endParaRPr lang="en-US" altLang="ja-JP" sz="2600" dirty="0"/>
+          </a:p>
+          <a:p>
+            <a:pPr marL="0" indent="0">
+              <a:buNone/>
+            </a:pPr>
+            <a:endParaRPr lang="en-US" altLang="ja-JP" sz="2600" dirty="0"/>
+          </a:p>
+          <a:p>
+            <a:pPr marL="0" indent="0">
+              <a:buNone/>
+            </a:pPr>
+            <a:r>
+              <a:rPr lang="ja-JP" altLang="en-US" sz="2600" dirty="0"/>
+              <a:t>・費用対効果</a:t>
+            </a:r>
+            <a:endParaRPr lang="en-US" altLang="ja-JP" sz="2600" dirty="0"/>
+          </a:p>
+          <a:p>
+            <a:pPr marL="0" indent="0">
+              <a:buNone/>
+            </a:pPr>
+            <a:endParaRPr lang="en-US" altLang="ja-JP" sz="2600" dirty="0"/>
+          </a:p>
+          <a:p>
+            <a:pPr marL="0" indent="0">
+              <a:buNone/>
+            </a:pPr>
+            <a:r>
+              <a:rPr lang="ja-JP" altLang="en-US" sz="2600" dirty="0"/>
+              <a:t>・</a:t>
+            </a:r>
+            <a:r>
+              <a:rPr lang="en-US" altLang="ja-JP" sz="2600" dirty="0"/>
+              <a:t>Amazon</a:t>
+            </a:r>
+            <a:r>
+              <a:rPr lang="ja-JP" altLang="en-US" sz="2600" dirty="0"/>
+              <a:t>への押し上げ効果は？</a:t>
             </a:r>
             <a:endParaRPr lang="en-US" altLang="ja-JP" sz="2600" dirty="0"/>
           </a:p>

</xml_diff>